<commit_message>
Fix mod drawer, add absentee removal, pure mobile voting, and custom missions
</commit_message>
<xml_diff>
--- a/Office_Heist_Host_Master_Guide.pptx
+++ b/Office_Heist_Host_Master_Guide.pptx
@@ -5,15 +5,15 @@
     <p:sldMasterId id="2147483648" r:id="rId1"/>
   </p:sldMasterIdLst>
   <p:sldIdLst>
-    <p:sldId id="256" r:id="rId7"/>
-    <p:sldId id="257" r:id="rId8"/>
-    <p:sldId id="258" r:id="rId9"/>
-    <p:sldId id="259" r:id="rId10"/>
-    <p:sldId id="260" r:id="rId11"/>
-    <p:sldId id="261" r:id="rId12"/>
-    <p:sldId id="262" r:id="rId13"/>
+    <p:sldId id="256" r:id="rId2"/>
+    <p:sldId id="257" r:id="rId3"/>
+    <p:sldId id="258" r:id="rId4"/>
+    <p:sldId id="259" r:id="rId5"/>
+    <p:sldId id="260" r:id="rId6"/>
+    <p:sldId id="261" r:id="rId7"/>
+    <p:sldId id="262" r:id="rId8"/>
   </p:sldIdLst>
-  <p:sldSz cx="12191695" cy="6858000" type="screen4x3"/>
+  <p:sldSz cx="12192000" cy="6858000"/>
   <p:notesSz cx="6858000" cy="9144000"/>
   <p:defaultTextStyle>
     <a:defPPr>
@@ -110,6 +110,22 @@
       </a:defRPr>
     </a:lvl9pPr>
   </p:defaultTextStyle>
+  <p:extLst>
+    <p:ext uri="{EFAFB233-063F-42B5-8137-9DF3F51BA10A}">
+      <p15:sldGuideLst xmlns:p15="http://schemas.microsoft.com/office/powerpoint/2012/main">
+        <p15:guide id="1" orient="horz" pos="2160">
+          <p15:clr>
+            <a:srgbClr val="A4A3A4"/>
+          </p15:clr>
+        </p15:guide>
+        <p15:guide id="2" pos="2880">
+          <p15:clr>
+            <a:srgbClr val="A4A3A4"/>
+          </p15:clr>
+        </p15:guide>
+      </p15:sldGuideLst>
+    </p:ext>
+  </p:extLst>
 </p:presentation>
 </file>
 
@@ -151,10 +167,9 @@
           <a:lstStyle/>
           <a:p>
             <a:r>
-              <a:rPr lang="en-US" smtClean="0"/>
+              <a:rPr lang="en-US"/>
               <a:t>Click to edit Master title style</a:t>
             </a:r>
-            <a:endParaRPr lang="en-US"/>
           </a:p>
         </p:txBody>
       </p:sp>
@@ -270,10 +285,9 @@
           </a:lstStyle>
           <a:p>
             <a:r>
-              <a:rPr lang="en-US" smtClean="0"/>
+              <a:rPr lang="en-US"/>
               <a:t>Click to edit Master subtitle style</a:t>
             </a:r>
-            <a:endParaRPr lang="en-US"/>
           </a:p>
         </p:txBody>
       </p:sp>
@@ -294,7 +308,7 @@
           <a:p>
             <a:fld id="{5BCAD085-E8A6-8845-BD4E-CB4CCA059FC4}" type="datetimeFigureOut">
               <a:rPr lang="en-US" smtClean="0"/>
-              <a:t>1/27/13</a:t>
+              <a:t>9/30/2026</a:t>
             </a:fld>
             <a:endParaRPr lang="en-US"/>
           </a:p>
@@ -388,10 +402,9 @@
           <a:lstStyle/>
           <a:p>
             <a:r>
-              <a:rPr lang="en-US" smtClean="0"/>
+              <a:rPr lang="en-US"/>
               <a:t>Click to edit Master title style</a:t>
             </a:r>
-            <a:endParaRPr lang="en-US"/>
           </a:p>
         </p:txBody>
       </p:sp>
@@ -412,38 +425,37 @@
           <a:p>
             <a:pPr lvl="0"/>
             <a:r>
-              <a:rPr lang="en-US" smtClean="0"/>
+              <a:rPr lang="en-US"/>
               <a:t>Click to edit Master text styles</a:t>
             </a:r>
           </a:p>
           <a:p>
             <a:pPr lvl="1"/>
             <a:r>
-              <a:rPr lang="en-US" smtClean="0"/>
+              <a:rPr lang="en-US"/>
               <a:t>Second level</a:t>
             </a:r>
           </a:p>
           <a:p>
             <a:pPr lvl="2"/>
             <a:r>
-              <a:rPr lang="en-US" smtClean="0"/>
+              <a:rPr lang="en-US"/>
               <a:t>Third level</a:t>
             </a:r>
           </a:p>
           <a:p>
             <a:pPr lvl="3"/>
             <a:r>
-              <a:rPr lang="en-US" smtClean="0"/>
+              <a:rPr lang="en-US"/>
               <a:t>Fourth level</a:t>
             </a:r>
           </a:p>
           <a:p>
             <a:pPr lvl="4"/>
             <a:r>
-              <a:rPr lang="en-US" smtClean="0"/>
+              <a:rPr lang="en-US"/>
               <a:t>Fifth level</a:t>
             </a:r>
-            <a:endParaRPr lang="en-US"/>
           </a:p>
         </p:txBody>
       </p:sp>
@@ -464,7 +476,7 @@
           <a:p>
             <a:fld id="{5BCAD085-E8A6-8845-BD4E-CB4CCA059FC4}" type="datetimeFigureOut">
               <a:rPr lang="en-US" smtClean="0"/>
-              <a:t>1/27/13</a:t>
+              <a:t>9/30/2026</a:t>
             </a:fld>
             <a:endParaRPr lang="en-US"/>
           </a:p>
@@ -563,10 +575,9 @@
           <a:lstStyle/>
           <a:p>
             <a:r>
-              <a:rPr lang="en-US" smtClean="0"/>
+              <a:rPr lang="en-US"/>
               <a:t>Click to edit Master title style</a:t>
             </a:r>
-            <a:endParaRPr lang="en-US"/>
           </a:p>
         </p:txBody>
       </p:sp>
@@ -592,38 +603,37 @@
           <a:p>
             <a:pPr lvl="0"/>
             <a:r>
-              <a:rPr lang="en-US" smtClean="0"/>
+              <a:rPr lang="en-US"/>
               <a:t>Click to edit Master text styles</a:t>
             </a:r>
           </a:p>
           <a:p>
             <a:pPr lvl="1"/>
             <a:r>
-              <a:rPr lang="en-US" smtClean="0"/>
+              <a:rPr lang="en-US"/>
               <a:t>Second level</a:t>
             </a:r>
           </a:p>
           <a:p>
             <a:pPr lvl="2"/>
             <a:r>
-              <a:rPr lang="en-US" smtClean="0"/>
+              <a:rPr lang="en-US"/>
               <a:t>Third level</a:t>
             </a:r>
           </a:p>
           <a:p>
             <a:pPr lvl="3"/>
             <a:r>
-              <a:rPr lang="en-US" smtClean="0"/>
+              <a:rPr lang="en-US"/>
               <a:t>Fourth level</a:t>
             </a:r>
           </a:p>
           <a:p>
             <a:pPr lvl="4"/>
             <a:r>
-              <a:rPr lang="en-US" smtClean="0"/>
+              <a:rPr lang="en-US"/>
               <a:t>Fifth level</a:t>
             </a:r>
-            <a:endParaRPr lang="en-US"/>
           </a:p>
         </p:txBody>
       </p:sp>
@@ -644,7 +654,7 @@
           <a:p>
             <a:fld id="{5BCAD085-E8A6-8845-BD4E-CB4CCA059FC4}" type="datetimeFigureOut">
               <a:rPr lang="en-US" smtClean="0"/>
-              <a:t>1/27/13</a:t>
+              <a:t>9/30/2026</a:t>
             </a:fld>
             <a:endParaRPr lang="en-US"/>
           </a:p>
@@ -738,10 +748,9 @@
           <a:lstStyle/>
           <a:p>
             <a:r>
-              <a:rPr lang="en-US" smtClean="0"/>
+              <a:rPr lang="en-US"/>
               <a:t>Click to edit Master title style</a:t>
             </a:r>
-            <a:endParaRPr lang="en-US"/>
           </a:p>
         </p:txBody>
       </p:sp>
@@ -762,38 +771,37 @@
           <a:p>
             <a:pPr lvl="0"/>
             <a:r>
-              <a:rPr lang="en-US" smtClean="0"/>
+              <a:rPr lang="en-US"/>
               <a:t>Click to edit Master text styles</a:t>
             </a:r>
           </a:p>
           <a:p>
             <a:pPr lvl="1"/>
             <a:r>
-              <a:rPr lang="en-US" smtClean="0"/>
+              <a:rPr lang="en-US"/>
               <a:t>Second level</a:t>
             </a:r>
           </a:p>
           <a:p>
             <a:pPr lvl="2"/>
             <a:r>
-              <a:rPr lang="en-US" smtClean="0"/>
+              <a:rPr lang="en-US"/>
               <a:t>Third level</a:t>
             </a:r>
           </a:p>
           <a:p>
             <a:pPr lvl="3"/>
             <a:r>
-              <a:rPr lang="en-US" smtClean="0"/>
+              <a:rPr lang="en-US"/>
               <a:t>Fourth level</a:t>
             </a:r>
           </a:p>
           <a:p>
             <a:pPr lvl="4"/>
             <a:r>
-              <a:rPr lang="en-US" smtClean="0"/>
+              <a:rPr lang="en-US"/>
               <a:t>Fifth level</a:t>
             </a:r>
-            <a:endParaRPr lang="en-US"/>
           </a:p>
         </p:txBody>
       </p:sp>
@@ -814,7 +822,7 @@
           <a:p>
             <a:fld id="{5BCAD085-E8A6-8845-BD4E-CB4CCA059FC4}" type="datetimeFigureOut">
               <a:rPr lang="en-US" smtClean="0"/>
-              <a:t>1/27/13</a:t>
+              <a:t>9/30/2026</a:t>
             </a:fld>
             <a:endParaRPr lang="en-US"/>
           </a:p>
@@ -917,10 +925,9 @@
           </a:lstStyle>
           <a:p>
             <a:r>
-              <a:rPr lang="en-US" smtClean="0"/>
+              <a:rPr lang="en-US"/>
               <a:t>Click to edit Master title style</a:t>
             </a:r>
-            <a:endParaRPr lang="en-US"/>
           </a:p>
         </p:txBody>
       </p:sp>
@@ -1037,7 +1044,7 @@
           <a:p>
             <a:pPr lvl="0"/>
             <a:r>
-              <a:rPr lang="en-US" smtClean="0"/>
+              <a:rPr lang="en-US"/>
               <a:t>Click to edit Master text styles</a:t>
             </a:r>
           </a:p>
@@ -1060,7 +1067,7 @@
           <a:p>
             <a:fld id="{5BCAD085-E8A6-8845-BD4E-CB4CCA059FC4}" type="datetimeFigureOut">
               <a:rPr lang="en-US" smtClean="0"/>
-              <a:t>1/27/13</a:t>
+              <a:t>9/30/2026</a:t>
             </a:fld>
             <a:endParaRPr lang="en-US"/>
           </a:p>
@@ -1154,10 +1161,9 @@
           <a:lstStyle/>
           <a:p>
             <a:r>
-              <a:rPr lang="en-US" smtClean="0"/>
+              <a:rPr lang="en-US"/>
               <a:t>Click to edit Master title style</a:t>
             </a:r>
-            <a:endParaRPr lang="en-US"/>
           </a:p>
         </p:txBody>
       </p:sp>
@@ -1211,38 +1217,37 @@
           <a:p>
             <a:pPr lvl="0"/>
             <a:r>
-              <a:rPr lang="en-US" smtClean="0"/>
+              <a:rPr lang="en-US"/>
               <a:t>Click to edit Master text styles</a:t>
             </a:r>
           </a:p>
           <a:p>
             <a:pPr lvl="1"/>
             <a:r>
-              <a:rPr lang="en-US" smtClean="0"/>
+              <a:rPr lang="en-US"/>
               <a:t>Second level</a:t>
             </a:r>
           </a:p>
           <a:p>
             <a:pPr lvl="2"/>
             <a:r>
-              <a:rPr lang="en-US" smtClean="0"/>
+              <a:rPr lang="en-US"/>
               <a:t>Third level</a:t>
             </a:r>
           </a:p>
           <a:p>
             <a:pPr lvl="3"/>
             <a:r>
-              <a:rPr lang="en-US" smtClean="0"/>
+              <a:rPr lang="en-US"/>
               <a:t>Fourth level</a:t>
             </a:r>
           </a:p>
           <a:p>
             <a:pPr lvl="4"/>
             <a:r>
-              <a:rPr lang="en-US" smtClean="0"/>
+              <a:rPr lang="en-US"/>
               <a:t>Fifth level</a:t>
             </a:r>
-            <a:endParaRPr lang="en-US"/>
           </a:p>
         </p:txBody>
       </p:sp>
@@ -1296,38 +1301,37 @@
           <a:p>
             <a:pPr lvl="0"/>
             <a:r>
-              <a:rPr lang="en-US" smtClean="0"/>
+              <a:rPr lang="en-US"/>
               <a:t>Click to edit Master text styles</a:t>
             </a:r>
           </a:p>
           <a:p>
             <a:pPr lvl="1"/>
             <a:r>
-              <a:rPr lang="en-US" smtClean="0"/>
+              <a:rPr lang="en-US"/>
               <a:t>Second level</a:t>
             </a:r>
           </a:p>
           <a:p>
             <a:pPr lvl="2"/>
             <a:r>
-              <a:rPr lang="en-US" smtClean="0"/>
+              <a:rPr lang="en-US"/>
               <a:t>Third level</a:t>
             </a:r>
           </a:p>
           <a:p>
             <a:pPr lvl="3"/>
             <a:r>
-              <a:rPr lang="en-US" smtClean="0"/>
+              <a:rPr lang="en-US"/>
               <a:t>Fourth level</a:t>
             </a:r>
           </a:p>
           <a:p>
             <a:pPr lvl="4"/>
             <a:r>
-              <a:rPr lang="en-US" smtClean="0"/>
+              <a:rPr lang="en-US"/>
               <a:t>Fifth level</a:t>
             </a:r>
-            <a:endParaRPr lang="en-US"/>
           </a:p>
         </p:txBody>
       </p:sp>
@@ -1348,7 +1352,7 @@
           <a:p>
             <a:fld id="{5BCAD085-E8A6-8845-BD4E-CB4CCA059FC4}" type="datetimeFigureOut">
               <a:rPr lang="en-US" smtClean="0"/>
-              <a:t>1/27/13</a:t>
+              <a:t>9/30/2026</a:t>
             </a:fld>
             <a:endParaRPr lang="en-US"/>
           </a:p>
@@ -1446,10 +1450,9 @@
           </a:lstStyle>
           <a:p>
             <a:r>
-              <a:rPr lang="en-US" smtClean="0"/>
+              <a:rPr lang="en-US"/>
               <a:t>Click to edit Master title style</a:t>
             </a:r>
-            <a:endParaRPr lang="en-US"/>
           </a:p>
         </p:txBody>
       </p:sp>
@@ -1512,7 +1515,7 @@
           <a:p>
             <a:pPr lvl="0"/>
             <a:r>
-              <a:rPr lang="en-US" smtClean="0"/>
+              <a:rPr lang="en-US"/>
               <a:t>Click to edit Master text styles</a:t>
             </a:r>
           </a:p>
@@ -1568,38 +1571,37 @@
           <a:p>
             <a:pPr lvl="0"/>
             <a:r>
-              <a:rPr lang="en-US" smtClean="0"/>
+              <a:rPr lang="en-US"/>
               <a:t>Click to edit Master text styles</a:t>
             </a:r>
           </a:p>
           <a:p>
             <a:pPr lvl="1"/>
             <a:r>
-              <a:rPr lang="en-US" smtClean="0"/>
+              <a:rPr lang="en-US"/>
               <a:t>Second level</a:t>
             </a:r>
           </a:p>
           <a:p>
             <a:pPr lvl="2"/>
             <a:r>
-              <a:rPr lang="en-US" smtClean="0"/>
+              <a:rPr lang="en-US"/>
               <a:t>Third level</a:t>
             </a:r>
           </a:p>
           <a:p>
             <a:pPr lvl="3"/>
             <a:r>
-              <a:rPr lang="en-US" smtClean="0"/>
+              <a:rPr lang="en-US"/>
               <a:t>Fourth level</a:t>
             </a:r>
           </a:p>
           <a:p>
             <a:pPr lvl="4"/>
             <a:r>
-              <a:rPr lang="en-US" smtClean="0"/>
+              <a:rPr lang="en-US"/>
               <a:t>Fifth level</a:t>
             </a:r>
-            <a:endParaRPr lang="en-US"/>
           </a:p>
         </p:txBody>
       </p:sp>
@@ -1662,7 +1664,7 @@
           <a:p>
             <a:pPr lvl="0"/>
             <a:r>
-              <a:rPr lang="en-US" smtClean="0"/>
+              <a:rPr lang="en-US"/>
               <a:t>Click to edit Master text styles</a:t>
             </a:r>
           </a:p>
@@ -1718,38 +1720,37 @@
           <a:p>
             <a:pPr lvl="0"/>
             <a:r>
-              <a:rPr lang="en-US" smtClean="0"/>
+              <a:rPr lang="en-US"/>
               <a:t>Click to edit Master text styles</a:t>
             </a:r>
           </a:p>
           <a:p>
             <a:pPr lvl="1"/>
             <a:r>
-              <a:rPr lang="en-US" smtClean="0"/>
+              <a:rPr lang="en-US"/>
               <a:t>Second level</a:t>
             </a:r>
           </a:p>
           <a:p>
             <a:pPr lvl="2"/>
             <a:r>
-              <a:rPr lang="en-US" smtClean="0"/>
+              <a:rPr lang="en-US"/>
               <a:t>Third level</a:t>
             </a:r>
           </a:p>
           <a:p>
             <a:pPr lvl="3"/>
             <a:r>
-              <a:rPr lang="en-US" smtClean="0"/>
+              <a:rPr lang="en-US"/>
               <a:t>Fourth level</a:t>
             </a:r>
           </a:p>
           <a:p>
             <a:pPr lvl="4"/>
             <a:r>
-              <a:rPr lang="en-US" smtClean="0"/>
+              <a:rPr lang="en-US"/>
               <a:t>Fifth level</a:t>
             </a:r>
-            <a:endParaRPr lang="en-US"/>
           </a:p>
         </p:txBody>
       </p:sp>
@@ -1770,7 +1771,7 @@
           <a:p>
             <a:fld id="{5BCAD085-E8A6-8845-BD4E-CB4CCA059FC4}" type="datetimeFigureOut">
               <a:rPr lang="en-US" smtClean="0"/>
-              <a:t>1/27/13</a:t>
+              <a:t>9/30/2026</a:t>
             </a:fld>
             <a:endParaRPr lang="en-US"/>
           </a:p>
@@ -1864,10 +1865,9 @@
           <a:lstStyle/>
           <a:p>
             <a:r>
-              <a:rPr lang="en-US" smtClean="0"/>
+              <a:rPr lang="en-US"/>
               <a:t>Click to edit Master title style</a:t>
             </a:r>
-            <a:endParaRPr lang="en-US"/>
           </a:p>
         </p:txBody>
       </p:sp>
@@ -1888,7 +1888,7 @@
           <a:p>
             <a:fld id="{5BCAD085-E8A6-8845-BD4E-CB4CCA059FC4}" type="datetimeFigureOut">
               <a:rPr lang="en-US" smtClean="0"/>
-              <a:t>1/27/13</a:t>
+              <a:t>9/30/2026</a:t>
             </a:fld>
             <a:endParaRPr lang="en-US"/>
           </a:p>
@@ -1983,7 +1983,7 @@
           <a:p>
             <a:fld id="{5BCAD085-E8A6-8845-BD4E-CB4CCA059FC4}" type="datetimeFigureOut">
               <a:rPr lang="en-US" smtClean="0"/>
-              <a:t>1/27/13</a:t>
+              <a:t>9/30/2026</a:t>
             </a:fld>
             <a:endParaRPr lang="en-US"/>
           </a:p>
@@ -2086,10 +2086,9 @@
           </a:lstStyle>
           <a:p>
             <a:r>
-              <a:rPr lang="en-US" smtClean="0"/>
+              <a:rPr lang="en-US"/>
               <a:t>Click to edit Master title style</a:t>
             </a:r>
-            <a:endParaRPr lang="en-US"/>
           </a:p>
         </p:txBody>
       </p:sp>
@@ -2143,38 +2142,37 @@
           <a:p>
             <a:pPr lvl="0"/>
             <a:r>
-              <a:rPr lang="en-US" smtClean="0"/>
+              <a:rPr lang="en-US"/>
               <a:t>Click to edit Master text styles</a:t>
             </a:r>
           </a:p>
           <a:p>
             <a:pPr lvl="1"/>
             <a:r>
-              <a:rPr lang="en-US" smtClean="0"/>
+              <a:rPr lang="en-US"/>
               <a:t>Second level</a:t>
             </a:r>
           </a:p>
           <a:p>
             <a:pPr lvl="2"/>
             <a:r>
-              <a:rPr lang="en-US" smtClean="0"/>
+              <a:rPr lang="en-US"/>
               <a:t>Third level</a:t>
             </a:r>
           </a:p>
           <a:p>
             <a:pPr lvl="3"/>
             <a:r>
-              <a:rPr lang="en-US" smtClean="0"/>
+              <a:rPr lang="en-US"/>
               <a:t>Fourth level</a:t>
             </a:r>
           </a:p>
           <a:p>
             <a:pPr lvl="4"/>
             <a:r>
-              <a:rPr lang="en-US" smtClean="0"/>
+              <a:rPr lang="en-US"/>
               <a:t>Fifth level</a:t>
             </a:r>
-            <a:endParaRPr lang="en-US"/>
           </a:p>
         </p:txBody>
       </p:sp>
@@ -2237,7 +2235,7 @@
           <a:p>
             <a:pPr lvl="0"/>
             <a:r>
-              <a:rPr lang="en-US" smtClean="0"/>
+              <a:rPr lang="en-US"/>
               <a:t>Click to edit Master text styles</a:t>
             </a:r>
           </a:p>
@@ -2260,7 +2258,7 @@
           <a:p>
             <a:fld id="{5BCAD085-E8A6-8845-BD4E-CB4CCA059FC4}" type="datetimeFigureOut">
               <a:rPr lang="en-US" smtClean="0"/>
-              <a:t>1/27/13</a:t>
+              <a:t>9/30/2026</a:t>
             </a:fld>
             <a:endParaRPr lang="en-US"/>
           </a:p>
@@ -2363,10 +2361,9 @@
           </a:lstStyle>
           <a:p>
             <a:r>
-              <a:rPr lang="en-US" smtClean="0"/>
+              <a:rPr lang="en-US"/>
               <a:t>Click to edit Master title style</a:t>
             </a:r>
-            <a:endParaRPr lang="en-US"/>
           </a:p>
         </p:txBody>
       </p:sp>
@@ -2490,7 +2487,7 @@
           <a:p>
             <a:pPr lvl="0"/>
             <a:r>
-              <a:rPr lang="en-US" smtClean="0"/>
+              <a:rPr lang="en-US"/>
               <a:t>Click to edit Master text styles</a:t>
             </a:r>
           </a:p>
@@ -2513,7 +2510,7 @@
           <a:p>
             <a:fld id="{5BCAD085-E8A6-8845-BD4E-CB4CCA059FC4}" type="datetimeFigureOut">
               <a:rPr lang="en-US" smtClean="0"/>
-              <a:t>1/27/13</a:t>
+              <a:t>9/30/2026</a:t>
             </a:fld>
             <a:endParaRPr lang="en-US"/>
           </a:p>
@@ -2622,10 +2619,9 @@
           <a:lstStyle/>
           <a:p>
             <a:r>
-              <a:rPr lang="en-US" smtClean="0"/>
+              <a:rPr lang="en-US"/>
               <a:t>Click to edit Master title style</a:t>
             </a:r>
-            <a:endParaRPr lang="en-US"/>
           </a:p>
         </p:txBody>
       </p:sp>
@@ -2656,38 +2652,37 @@
           <a:p>
             <a:pPr lvl="0"/>
             <a:r>
-              <a:rPr lang="en-US" smtClean="0"/>
+              <a:rPr lang="en-US"/>
               <a:t>Click to edit Master text styles</a:t>
             </a:r>
           </a:p>
           <a:p>
             <a:pPr lvl="1"/>
             <a:r>
-              <a:rPr lang="en-US" smtClean="0"/>
+              <a:rPr lang="en-US"/>
               <a:t>Second level</a:t>
             </a:r>
           </a:p>
           <a:p>
             <a:pPr lvl="2"/>
             <a:r>
-              <a:rPr lang="en-US" smtClean="0"/>
+              <a:rPr lang="en-US"/>
               <a:t>Third level</a:t>
             </a:r>
           </a:p>
           <a:p>
             <a:pPr lvl="3"/>
             <a:r>
-              <a:rPr lang="en-US" smtClean="0"/>
+              <a:rPr lang="en-US"/>
               <a:t>Fourth level</a:t>
             </a:r>
           </a:p>
           <a:p>
             <a:pPr lvl="4"/>
             <a:r>
-              <a:rPr lang="en-US" smtClean="0"/>
+              <a:rPr lang="en-US"/>
               <a:t>Fifth level</a:t>
             </a:r>
-            <a:endParaRPr lang="en-US"/>
           </a:p>
         </p:txBody>
       </p:sp>
@@ -2726,7 +2721,7 @@
           <a:p>
             <a:fld id="{5BCAD085-E8A6-8845-BD4E-CB4CCA059FC4}" type="datetimeFigureOut">
               <a:rPr lang="en-US" smtClean="0"/>
-              <a:t>1/27/13</a:t>
+              <a:t>9/30/2026</a:t>
             </a:fld>
             <a:endParaRPr lang="en-US"/>
           </a:p>
@@ -3085,7 +3080,7 @@
 </file>
 
 <file path=ppt/slides/slide1.xml><?xml version="1.0" encoding="utf-8"?>
-<p:sld xmlns:a="http://schemas.openxmlformats.org/drawingml/2006/main" xmlns:p="http://schemas.openxmlformats.org/presentationml/2006/main" xmlns:r="http://schemas.openxmlformats.org/officeDocument/2006/relationships">
+<p:sld xmlns:a="http://schemas.openxmlformats.org/drawingml/2006/main" xmlns:r="http://schemas.openxmlformats.org/officeDocument/2006/relationships" xmlns:p="http://schemas.openxmlformats.org/presentationml/2006/main">
   <p:cSld>
     <p:bg>
       <p:bgPr>
@@ -3101,7 +3096,14 @@
         <p:cNvGrpSpPr/>
         <p:nvPr/>
       </p:nvGrpSpPr>
-      <p:grpSpPr/>
+      <p:grpSpPr>
+        <a:xfrm>
+          <a:off x="0" y="0"/>
+          <a:ext cx="0" cy="0"/>
+          <a:chOff x="0" y="0"/>
+          <a:chExt cx="0" cy="0"/>
+        </a:xfrm>
+      </p:grpSpPr>
       <p:sp>
         <p:nvSpPr>
           <p:cNvPr id="2" name="Rectangle 1"/>
@@ -3142,6 +3144,7 @@
           <a:lstStyle/>
           <a:p>
             <a:pPr algn="ctr"/>
+            <a:endParaRPr/>
           </a:p>
         </p:txBody>
       </p:sp>
@@ -3227,7 +3230,7 @@
 </file>
 
 <file path=ppt/slides/slide2.xml><?xml version="1.0" encoding="utf-8"?>
-<p:sld xmlns:a="http://schemas.openxmlformats.org/drawingml/2006/main" xmlns:p="http://schemas.openxmlformats.org/presentationml/2006/main" xmlns:r="http://schemas.openxmlformats.org/officeDocument/2006/relationships">
+<p:sld xmlns:a="http://schemas.openxmlformats.org/drawingml/2006/main" xmlns:r="http://schemas.openxmlformats.org/officeDocument/2006/relationships" xmlns:p="http://schemas.openxmlformats.org/presentationml/2006/main">
   <p:cSld>
     <p:bg>
       <p:bgPr>
@@ -3243,7 +3246,14 @@
         <p:cNvGrpSpPr/>
         <p:nvPr/>
       </p:nvGrpSpPr>
-      <p:grpSpPr/>
+      <p:grpSpPr>
+        <a:xfrm>
+          <a:off x="0" y="0"/>
+          <a:ext cx="0" cy="0"/>
+          <a:chOff x="0" y="0"/>
+          <a:chExt cx="0" cy="0"/>
+        </a:xfrm>
+      </p:grpSpPr>
       <p:sp>
         <p:nvSpPr>
           <p:cNvPr id="2" name="TextBox 1"/>
@@ -3356,6 +3366,7 @@
           <a:lstStyle/>
           <a:p>
             <a:pPr algn="ctr"/>
+            <a:endParaRPr/>
           </a:p>
         </p:txBody>
       </p:sp>
@@ -3511,6 +3522,7 @@
           <a:lstStyle/>
           <a:p>
             <a:pPr algn="ctr"/>
+            <a:endParaRPr/>
           </a:p>
         </p:txBody>
       </p:sp>
@@ -3666,6 +3678,7 @@
           <a:lstStyle/>
           <a:p>
             <a:pPr algn="ctr"/>
+            <a:endParaRPr/>
           </a:p>
         </p:txBody>
       </p:sp>
@@ -3788,7 +3801,7 @@
 </file>
 
 <file path=ppt/slides/slide3.xml><?xml version="1.0" encoding="utf-8"?>
-<p:sld xmlns:a="http://schemas.openxmlformats.org/drawingml/2006/main" xmlns:p="http://schemas.openxmlformats.org/presentationml/2006/main" xmlns:r="http://schemas.openxmlformats.org/officeDocument/2006/relationships">
+<p:sld xmlns:a="http://schemas.openxmlformats.org/drawingml/2006/main" xmlns:r="http://schemas.openxmlformats.org/officeDocument/2006/relationships" xmlns:p="http://schemas.openxmlformats.org/presentationml/2006/main">
   <p:cSld>
     <p:bg>
       <p:bgPr>
@@ -3804,7 +3817,14 @@
         <p:cNvGrpSpPr/>
         <p:nvPr/>
       </p:nvGrpSpPr>
-      <p:grpSpPr/>
+      <p:grpSpPr>
+        <a:xfrm>
+          <a:off x="0" y="0"/>
+          <a:ext cx="0" cy="0"/>
+          <a:chOff x="0" y="0"/>
+          <a:chExt cx="0" cy="0"/>
+        </a:xfrm>
+      </p:grpSpPr>
       <p:sp>
         <p:nvSpPr>
           <p:cNvPr id="2" name="TextBox 1"/>
@@ -3917,6 +3937,7 @@
           <a:lstStyle/>
           <a:p>
             <a:pPr algn="ctr"/>
+            <a:endParaRPr/>
           </a:p>
         </p:txBody>
       </p:sp>
@@ -3929,7 +3950,7 @@
         <p:spPr>
           <a:xfrm>
             <a:off x="1005840" y="2011680"/>
-            <a:ext cx="4572000" cy="4023360"/>
+            <a:ext cx="4572000" cy="2534027"/>
           </a:xfrm>
           <a:prstGeom prst="rect">
             <a:avLst/>
@@ -3953,6 +3974,7 @@
               </a:defRPr>
             </a:pPr>
             <a:r>
+              <a:rPr dirty="0"/>
               <a:t>💻 LAPTOP MODERATOR DESK</a:t>
             </a:r>
           </a:p>
@@ -3968,6 +3990,7 @@
               </a:defRPr>
             </a:pPr>
             <a:r>
+              <a:rPr dirty="0"/>
               <a:t>• Location: Top navigation bar on big screen ('🛡️ Moderator Desk').</a:t>
             </a:r>
           </a:p>
@@ -3983,7 +4006,16 @@
               </a:defRPr>
             </a:pPr>
             <a:r>
-              <a:t>• Protected by PIN: 2026.</a:t>
+              <a:rPr dirty="0"/>
+              <a:t>• Protected by PIN: </a:t>
+            </a:r>
+            <a:r>
+              <a:rPr lang="en-US" dirty="0"/>
+              <a:t>####</a:t>
+            </a:r>
+            <a:r>
+              <a:rPr dirty="0"/>
+              <a:t>.</a:t>
             </a:r>
           </a:p>
           <a:p>
@@ -3998,6 +4030,7 @@
               </a:defRPr>
             </a:pPr>
             <a:r>
+              <a:rPr dirty="0"/>
               <a:t>• Reveals the 5 Secret Saboteurs with 1-click 'Copy Whisper' buttons.</a:t>
             </a:r>
           </a:p>
@@ -4013,6 +4046,7 @@
               </a:defRPr>
             </a:pPr>
             <a:r>
+              <a:rPr dirty="0"/>
               <a:t>• Displays full game history log with timestamped event records.</a:t>
             </a:r>
           </a:p>
@@ -4028,6 +4062,7 @@
               </a:defRPr>
             </a:pPr>
             <a:r>
+              <a:rPr dirty="0"/>
               <a:t>• Provides manual override buttons: Force Leader Rotate &amp; Full Game Reset.</a:t>
             </a:r>
           </a:p>
@@ -4075,6 +4110,7 @@
           <a:lstStyle/>
           <a:p>
             <a:pPr algn="ctr"/>
+            <a:endParaRPr/>
           </a:p>
         </p:txBody>
       </p:sp>
@@ -4230,7 +4266,7 @@
 </file>
 
 <file path=ppt/slides/slide4.xml><?xml version="1.0" encoding="utf-8"?>
-<p:sld xmlns:a="http://schemas.openxmlformats.org/drawingml/2006/main" xmlns:p="http://schemas.openxmlformats.org/presentationml/2006/main" xmlns:r="http://schemas.openxmlformats.org/officeDocument/2006/relationships">
+<p:sld xmlns:a="http://schemas.openxmlformats.org/drawingml/2006/main" xmlns:r="http://schemas.openxmlformats.org/officeDocument/2006/relationships" xmlns:p="http://schemas.openxmlformats.org/presentationml/2006/main">
   <p:cSld>
     <p:bg>
       <p:bgPr>
@@ -4246,7 +4282,14 @@
         <p:cNvGrpSpPr/>
         <p:nvPr/>
       </p:nvGrpSpPr>
-      <p:grpSpPr/>
+      <p:grpSpPr>
+        <a:xfrm>
+          <a:off x="0" y="0"/>
+          <a:ext cx="0" cy="0"/>
+          <a:chOff x="0" y="0"/>
+          <a:chExt cx="0" cy="0"/>
+        </a:xfrm>
+      </p:grpSpPr>
       <p:sp>
         <p:nvSpPr>
           <p:cNvPr id="2" name="TextBox 1"/>
@@ -4359,6 +4402,7 @@
           <a:lstStyle/>
           <a:p>
             <a:pPr algn="ctr"/>
+            <a:endParaRPr/>
           </a:p>
         </p:txBody>
       </p:sp>
@@ -4496,7 +4540,7 @@
 </file>
 
 <file path=ppt/slides/slide5.xml><?xml version="1.0" encoding="utf-8"?>
-<p:sld xmlns:a="http://schemas.openxmlformats.org/drawingml/2006/main" xmlns:p="http://schemas.openxmlformats.org/presentationml/2006/main" xmlns:r="http://schemas.openxmlformats.org/officeDocument/2006/relationships">
+<p:sld xmlns:a="http://schemas.openxmlformats.org/drawingml/2006/main" xmlns:r="http://schemas.openxmlformats.org/officeDocument/2006/relationships" xmlns:p="http://schemas.openxmlformats.org/presentationml/2006/main">
   <p:cSld>
     <p:bg>
       <p:bgPr>
@@ -4512,7 +4556,14 @@
         <p:cNvGrpSpPr/>
         <p:nvPr/>
       </p:nvGrpSpPr>
-      <p:grpSpPr/>
+      <p:grpSpPr>
+        <a:xfrm>
+          <a:off x="0" y="0"/>
+          <a:ext cx="0" cy="0"/>
+          <a:chOff x="0" y="0"/>
+          <a:chExt cx="0" cy="0"/>
+        </a:xfrm>
+      </p:grpSpPr>
       <p:sp>
         <p:nvSpPr>
           <p:cNvPr id="2" name="TextBox 1"/>
@@ -4625,6 +4676,7 @@
           <a:lstStyle/>
           <a:p>
             <a:pPr algn="ctr"/>
+            <a:endParaRPr/>
           </a:p>
         </p:txBody>
       </p:sp>
@@ -4717,6 +4769,7 @@
           <a:lstStyle/>
           <a:p>
             <a:pPr algn="ctr"/>
+            <a:endParaRPr/>
           </a:p>
         </p:txBody>
       </p:sp>
@@ -4809,6 +4862,7 @@
           <a:lstStyle/>
           <a:p>
             <a:pPr algn="ctr"/>
+            <a:endParaRPr/>
           </a:p>
         </p:txBody>
       </p:sp>
@@ -4901,6 +4955,7 @@
           <a:lstStyle/>
           <a:p>
             <a:pPr algn="ctr"/>
+            <a:endParaRPr/>
           </a:p>
         </p:txBody>
       </p:sp>
@@ -4993,6 +5048,7 @@
           <a:lstStyle/>
           <a:p>
             <a:pPr algn="ctr"/>
+            <a:endParaRPr/>
           </a:p>
         </p:txBody>
       </p:sp>
@@ -5052,7 +5108,7 @@
 </file>
 
 <file path=ppt/slides/slide6.xml><?xml version="1.0" encoding="utf-8"?>
-<p:sld xmlns:a="http://schemas.openxmlformats.org/drawingml/2006/main" xmlns:p="http://schemas.openxmlformats.org/presentationml/2006/main" xmlns:r="http://schemas.openxmlformats.org/officeDocument/2006/relationships">
+<p:sld xmlns:a="http://schemas.openxmlformats.org/drawingml/2006/main" xmlns:r="http://schemas.openxmlformats.org/officeDocument/2006/relationships" xmlns:p="http://schemas.openxmlformats.org/presentationml/2006/main">
   <p:cSld>
     <p:bg>
       <p:bgPr>
@@ -5068,7 +5124,14 @@
         <p:cNvGrpSpPr/>
         <p:nvPr/>
       </p:nvGrpSpPr>
-      <p:grpSpPr/>
+      <p:grpSpPr>
+        <a:xfrm>
+          <a:off x="0" y="0"/>
+          <a:ext cx="0" cy="0"/>
+          <a:chOff x="0" y="0"/>
+          <a:chExt cx="0" cy="0"/>
+        </a:xfrm>
+      </p:grpSpPr>
       <p:sp>
         <p:nvSpPr>
           <p:cNvPr id="2" name="TextBox 1"/>
@@ -5181,6 +5244,7 @@
           <a:lstStyle/>
           <a:p>
             <a:pPr algn="ctr"/>
+            <a:endParaRPr/>
           </a:p>
         </p:txBody>
       </p:sp>
@@ -5273,6 +5337,7 @@
           <a:lstStyle/>
           <a:p>
             <a:pPr algn="ctr"/>
+            <a:endParaRPr/>
           </a:p>
         </p:txBody>
       </p:sp>
@@ -5365,6 +5430,7 @@
           <a:lstStyle/>
           <a:p>
             <a:pPr algn="ctr"/>
+            <a:endParaRPr/>
           </a:p>
         </p:txBody>
       </p:sp>
@@ -5457,6 +5523,7 @@
           <a:lstStyle/>
           <a:p>
             <a:pPr algn="ctr"/>
+            <a:endParaRPr/>
           </a:p>
         </p:txBody>
       </p:sp>
@@ -5516,7 +5583,7 @@
 </file>
 
 <file path=ppt/slides/slide7.xml><?xml version="1.0" encoding="utf-8"?>
-<p:sld xmlns:a="http://schemas.openxmlformats.org/drawingml/2006/main" xmlns:p="http://schemas.openxmlformats.org/presentationml/2006/main" xmlns:r="http://schemas.openxmlformats.org/officeDocument/2006/relationships">
+<p:sld xmlns:a="http://schemas.openxmlformats.org/drawingml/2006/main" xmlns:r="http://schemas.openxmlformats.org/officeDocument/2006/relationships" xmlns:p="http://schemas.openxmlformats.org/presentationml/2006/main">
   <p:cSld>
     <p:bg>
       <p:bgPr>
@@ -5532,7 +5599,14 @@
         <p:cNvGrpSpPr/>
         <p:nvPr/>
       </p:nvGrpSpPr>
-      <p:grpSpPr/>
+      <p:grpSpPr>
+        <a:xfrm>
+          <a:off x="0" y="0"/>
+          <a:ext cx="0" cy="0"/>
+          <a:chOff x="0" y="0"/>
+          <a:chExt cx="0" cy="0"/>
+        </a:xfrm>
+      </p:grpSpPr>
       <p:sp>
         <p:nvSpPr>
           <p:cNvPr id="2" name="TextBox 1"/>
@@ -5643,6 +5717,7 @@
           <a:lstStyle/>
           <a:p>
             <a:pPr algn="ctr"/>
+            <a:endParaRPr/>
           </a:p>
         </p:txBody>
       </p:sp>
@@ -5721,6 +5796,7 @@
           <a:lstStyle/>
           <a:p>
             <a:pPr algn="ctr"/>
+            <a:endParaRPr/>
           </a:p>
         </p:txBody>
       </p:sp>
@@ -5799,6 +5875,7 @@
           <a:lstStyle/>
           <a:p>
             <a:pPr algn="ctr"/>
+            <a:endParaRPr/>
           </a:p>
         </p:txBody>
       </p:sp>
@@ -5877,6 +5954,7 @@
           <a:lstStyle/>
           <a:p>
             <a:pPr algn="ctr"/>
+            <a:endParaRPr/>
           </a:p>
         </p:txBody>
       </p:sp>
@@ -5955,6 +6033,7 @@
           <a:lstStyle/>
           <a:p>
             <a:pPr algn="ctr"/>
+            <a:endParaRPr/>
           </a:p>
         </p:txBody>
       </p:sp>
@@ -6035,6 +6114,7 @@
           <a:lstStyle/>
           <a:p>
             <a:pPr algn="ctr"/>
+            <a:endParaRPr/>
           </a:p>
         </p:txBody>
       </p:sp>
@@ -6113,6 +6193,7 @@
           <a:lstStyle/>
           <a:p>
             <a:pPr algn="ctr"/>
+            <a:endParaRPr/>
           </a:p>
         </p:txBody>
       </p:sp>

</xml_diff>